<commit_message>
Regenerate risk-engines deck for the simplified UI readout
Slide 9 (UI readouts & case-level averaging) now describes what the
Risk Signals panel actually shows after the latest UI pass:

  - MAIN: contribution in points (0..100 scale, same as overall)
  - SECONDARY: share of case risk (sums to 100 %)
  - NARRATIVE: context-aware one-liner per engine

Explicitly notes that raw engine severity and engine weights are no
longer exposed in the UI (to avoid inviting questions about weight
tuning) but remain in this deck and backend logs.

The floor/cap non-linearity caveat stays, reworded toward "why the
four contributions SUM APPROXIMATELY to the overall" rather than the
previous "shares are an approximation" framing — both metrics matter.

Case-level running-mean math unchanged; added a line noting that
contribution pts and share are computed from the case-level engine
averages produced by that mean.

Co-Authored-By: Claude Opus 4.7 (1M context) <noreply@anthropic.com>
</commit_message>
<xml_diff>
--- a/docs/risk_engines.pptx
+++ b/docs/risk_engines.pptx
@@ -7995,7 +7995,7 @@
                 </a:solidFill>
                 <a:latin typeface="Calibri"/>
               </a:rPr>
-              <a:t>Contribution shares &amp; case-level averaging</a:t>
+              <a:t>UI readouts &amp; case-level averaging</a:t>
             </a:r>
           </a:p>
         </p:txBody>
@@ -8046,7 +8046,7 @@
                 </a:solidFill>
                 <a:latin typeface="Calibri"/>
               </a:rPr>
-              <a:t>How the per-engine and overall figures in the C&amp;T UI are computed</a:t>
+              <a:t>What the C&amp;T Risk Signals panel shows, and how the backend produces it</a:t>
             </a:r>
           </a:p>
         </p:txBody>
@@ -8060,7 +8060,7 @@
         <p:spPr>
           <a:xfrm>
             <a:off x="457200" y="1188720"/>
-            <a:ext cx="5669280" cy="2560320"/>
+            <a:ext cx="5669280" cy="3108960"/>
           </a:xfrm>
           <a:prstGeom prst="rect">
             <a:avLst/>
@@ -8101,7 +8101,7 @@
                 </a:solidFill>
                 <a:latin typeface="Calibri"/>
               </a:rPr>
-              <a:t>Per-engine CONTRIBUTION SHARE (UI)</a:t>
+              <a:t>Risk Signals panel — two numbers per engine</a:t>
             </a:r>
           </a:p>
           <a:p>
@@ -8113,7 +8113,7 @@
                 </a:solidFill>
                 <a:latin typeface="Calibri"/>
               </a:rPr>
-              <a:t>• For each engine: weighted = engine_avg × ENGINE_WEIGHTS[engine].</a:t>
+              <a:t>• MAIN: contribution in POINTS, on the same 0..100 scale as the overall case risk score. A bar visualises each contribution.</a:t>
             </a:r>
           </a:p>
           <a:p>
@@ -8125,7 +8125,7 @@
                 </a:solidFill>
                 <a:latin typeface="Calibri"/>
               </a:rPr>
-              <a:t>• Total = sum of weighted contributions across the 4 engines.</a:t>
+              <a:t>• SECONDARY (right-aligned, small): engine's SHARE of the case risk (its weighted contribution / sum of the four weighted contributions, normalised to 100 %).</a:t>
             </a:r>
           </a:p>
           <a:p>
@@ -8137,7 +8137,7 @@
                 </a:solidFill>
                 <a:latin typeface="Calibri"/>
               </a:rPr>
-              <a:t>• Share displayed in 'Risk Signals' panel = weighted / total × 100 %.</a:t>
+              <a:t>• Intended reading: the MAIN number tells how much this signal adds to the overall score; the SHARE tells which signal dominates relative to the others.</a:t>
             </a:r>
           </a:p>
           <a:p>
@@ -8149,7 +8149,7 @@
                 </a:solidFill>
                 <a:latin typeface="Calibri"/>
               </a:rPr>
-              <a:t>• By construction the four shares sum to ≈ 100 %, so officers can eyeball which engine dominates the case.</a:t>
+              <a:t>• NARRATIVE: each row carries a context-aware one-liner — fires / mild / quiet — so officers see what the engine is saying without reading raw scores.</a:t>
             </a:r>
           </a:p>
           <a:p>
@@ -8161,7 +8161,7 @@
                 </a:solidFill>
                 <a:latin typeface="Calibri"/>
               </a:rPr>
-              <a:t>• Raw engine severity is also shown underneath the share (the band that set the pre-baked value — 0.02–0.08 quiet, 0.55–0.70 firing).</a:t>
+              <a:t>• Raw engine severity and engine weights are NOT displayed in the UI (avoid inviting questions about weight tuning). They remain in the backend logs and this deck.</a:t>
             </a:r>
           </a:p>
         </p:txBody>
@@ -8175,7 +8175,7 @@
         <p:spPr>
           <a:xfrm>
             <a:off x="6400800" y="1188720"/>
-            <a:ext cx="5303520" cy="2560320"/>
+            <a:ext cx="5303520" cy="3108960"/>
           </a:xfrm>
           <a:prstGeom prst="rect">
             <a:avLst/>
@@ -8252,7 +8252,7 @@
                 </a:solidFill>
                 <a:latin typeface="Calibri"/>
               </a:rPr>
-              <a:t>•   Engine_X_new  = (Engine_X_old × (n-1) + order_Engine_X) / n</a:t>
+              <a:t>•   Engine_X_new = (Engine_X_old × (n-1) + order_Engine_X) / n</a:t>
             </a:r>
           </a:p>
           <a:p>
@@ -8264,7 +8264,7 @@
                 </a:solidFill>
                 <a:latin typeface="Calibri"/>
               </a:rPr>
-              <a:t>•   Overall_new   = (Overall_old  × (n-1) + order_score)   / n</a:t>
+              <a:t>•   Overall_new  = (Overall_old  × (n-1) + order_score)    / n</a:t>
             </a:r>
           </a:p>
           <a:p>
@@ -8277,6 +8277,18 @@
                 <a:latin typeface="Calibri"/>
               </a:rPr>
               <a:t>• Each engine field on Sales_Order_Case is an arithmetic mean across every order in the case — not a snapshot of the first transaction.</a:t>
+            </a:r>
+          </a:p>
+          <a:p>
+            <a:pPr algn="l"/>
+            <a:r>
+              <a:rPr sz="1200">
+                <a:solidFill>
+                  <a:srgbClr val="222222"/>
+                </a:solidFill>
+                <a:latin typeface="Calibri"/>
+              </a:rPr>
+              <a:t>• Contribution pts and share used in the UI are computed from these case-level averages.</a:t>
             </a:r>
           </a:p>
         </p:txBody>
@@ -8289,8 +8301,8 @@
         </p:nvSpPr>
         <p:spPr>
           <a:xfrm>
-            <a:off x="457200" y="3931920"/>
-            <a:ext cx="11247120" cy="2560320"/>
+            <a:off x="457200" y="4480560"/>
+            <a:ext cx="11247120" cy="2103120"/>
           </a:xfrm>
           <a:prstGeom prst="rect">
             <a:avLst/>
@@ -8331,7 +8343,7 @@
                 </a:solidFill>
                 <a:latin typeface="Calibri"/>
               </a:rPr>
-              <a:t>⚠ Non-linearity caveat — shares are an approximation</a:t>
+              <a:t>⚠ Why the contributions only SUM APPROXIMATELY to the overall</a:t>
             </a:r>
           </a:p>
           <a:p>
@@ -8343,7 +8355,7 @@
                 </a:solidFill>
                 <a:latin typeface="Calibri"/>
               </a:rPr>
-              <a:t>• Per-order score passes through the weighted sum AND the vat_ratio floor AND the min(1.0, …) cap. Only the linear part (weighted sum) commutes with averaging.</a:t>
+              <a:t>• Per-order score passes through the weighted sum AND the vat_ratio floor AND the min(1.0, …) cap. Only the weighted-sum part commutes with averaging across orders.</a:t>
             </a:r>
           </a:p>
           <a:p>
@@ -8355,7 +8367,7 @@
                 </a:solidFill>
                 <a:latin typeface="Calibri"/>
               </a:rPr>
-              <a:t>• Consequence: Overall_Case_Risk_Score ≠ Σ ENGINE_WEIGHTS × Engine_X_avg whenever the floor or the cap fired on any order in the case.</a:t>
+              <a:t>• Consequence: Σ (ENGINE_WEIGHTS × Engine_X_avg) ≠ Overall_Case_Risk_Score whenever the floor or the cap fired on any order in the case — small residual on the order of a few points.</a:t>
             </a:r>
           </a:p>
           <a:p>
@@ -8367,19 +8379,7 @@
                 </a:solidFill>
                 <a:latin typeface="Calibri"/>
               </a:rPr>
-              <a:t>• For cases where no order ever crossed the floor (raw vat_ratio &lt; 0.30 everywhere) and no order ever hit the cap (total weighted ≤ 1.0), the two are exactly equal and the shares reconstruct the overall.</a:t>
-            </a:r>
-          </a:p>
-          <a:p>
-            <a:pPr algn="l"/>
-            <a:r>
-              <a:rPr sz="1200">
-                <a:solidFill>
-                  <a:srgbClr val="222222"/>
-                </a:solidFill>
-                <a:latin typeface="Calibri"/>
-              </a:rPr>
-              <a:t>• For cases where floor/cap fired on some orders, the displayed shares still sum to 100 % and still rank engines correctly by contribution, but reconstructing the overall from them involves a small residual that carries the floor/cap effect.</a:t>
+              <a:t>• Officer-facing implication: the four contribution bars sum to roughly the overall score; shares sum to 100 %. Both are approximations of the same underlying case-level risk, useful for different questions.</a:t>
             </a:r>
           </a:p>
         </p:txBody>

</xml_diff>